<commit_message>
Updated data for Lily
</commit_message>
<xml_diff>
--- a/hearth_pitch_deck.pptx
+++ b/hearth_pitch_deck.pptx
@@ -10644,7 +10644,7 @@
         </p:nvSpPr>
         <p:spPr>
           <a:xfrm>
-            <a:off x="0" y="868680"/>
+            <a:off x="0" y="1447035"/>
             <a:ext cx="12188952" cy="1280160"/>
           </a:xfrm>
           <a:prstGeom prst="rect">
@@ -10660,7 +10660,7 @@
           <a:p>
             <a:pPr algn="ctr"/>
             <a:r>
-              <a:rPr sz="7200" b="0" i="0">
+              <a:rPr sz="7200" b="0" i="0" dirty="0">
                 <a:solidFill>
                   <a:srgbClr val="D04C14"/>
                 </a:solidFill>
@@ -10679,7 +10679,7 @@
         </p:nvSpPr>
         <p:spPr>
           <a:xfrm>
-            <a:off x="0" y="1874519"/>
+            <a:off x="-127" y="2318002"/>
             <a:ext cx="12188952" cy="1097280"/>
           </a:xfrm>
           <a:prstGeom prst="rect">
@@ -10714,7 +10714,7 @@
         </p:nvSpPr>
         <p:spPr>
           <a:xfrm>
-            <a:off x="2743200" y="2926080"/>
+            <a:off x="2788920" y="3493006"/>
             <a:ext cx="6702552" cy="36576"/>
           </a:xfrm>
           <a:prstGeom prst="rect">
@@ -10758,7 +10758,7 @@
         </p:nvSpPr>
         <p:spPr>
           <a:xfrm>
-            <a:off x="457200" y="3063240"/>
+            <a:off x="502920" y="3680458"/>
             <a:ext cx="11274552" cy="594360"/>
           </a:xfrm>
           <a:prstGeom prst="rect">
@@ -10774,7 +10774,7 @@
           <a:p>
             <a:pPr algn="ctr"/>
             <a:r>
-              <a:rPr sz="2100" b="0" i="1">
+              <a:rPr sz="2100" b="0" i="1" dirty="0">
                 <a:solidFill>
                   <a:srgbClr val="6A4220"/>
                 </a:solidFill>
@@ -10787,84 +10787,49 @@
       </p:sp>
       <p:sp>
         <p:nvSpPr>
-          <p:cNvPr id="12" name="TextBox 11"/>
-          <p:cNvSpPr txBox="1"/>
-          <p:nvPr/>
-        </p:nvSpPr>
-        <p:spPr>
-          <a:xfrm>
-            <a:off x="457200" y="3749039"/>
-            <a:ext cx="11274552" cy="411480"/>
-          </a:xfrm>
-          <a:prstGeom prst="rect">
-            <a:avLst/>
-          </a:prstGeom>
-          <a:noFill/>
-        </p:spPr>
-        <p:txBody>
-          <a:bodyPr wrap="square">
-            <a:spAutoFit/>
-          </a:bodyPr>
-          <a:lstStyle/>
-          <a:p>
-            <a:pPr algn="ctr"/>
-            <a:r>
-              <a:rPr sz="1300" b="0" i="0">
-                <a:solidFill>
-                  <a:srgbClr val="9E7248"/>
-                </a:solidFill>
-                <a:latin typeface="Calibri"/>
-              </a:rPr>
-              <a:t>FastAPI  |  OpenAI GPT-4o  |  fpdf2  |  ElevenLabs  |  Vanilla JS</a:t>
-            </a:r>
-          </a:p>
-        </p:txBody>
-      </p:sp>
-      <p:sp>
-        <p:nvSpPr>
-          <p:cNvPr id="13" name="TextBox 12"/>
-          <p:cNvSpPr txBox="1"/>
-          <p:nvPr/>
-        </p:nvSpPr>
-        <p:spPr>
-          <a:xfrm>
-            <a:off x="457200" y="4224528"/>
-            <a:ext cx="11274552" cy="384048"/>
-          </a:xfrm>
-          <a:prstGeom prst="rect">
-            <a:avLst/>
-          </a:prstGeom>
-          <a:noFill/>
-        </p:spPr>
-        <p:txBody>
-          <a:bodyPr wrap="square">
-            <a:spAutoFit/>
-          </a:bodyPr>
-          <a:lstStyle/>
-          <a:p>
-            <a:pPr algn="ctr"/>
-            <a:r>
-              <a:rPr sz="1200" b="0" i="0">
-                <a:solidFill>
-                  <a:srgbClr val="9E7248"/>
-                </a:solidFill>
-                <a:latin typeface="Calibri"/>
-              </a:rPr>
-              <a:t>Nikhil Gajula  |  BUAN 6V99 -- AI Agentic Systems  |  Spring 2026</a:t>
-            </a:r>
-          </a:p>
-        </p:txBody>
-      </p:sp>
-      <p:sp>
-        <p:nvSpPr>
-          <p:cNvPr id="14" name="Rectangle 13"/>
+          <p:cNvPr id="15" name="TextBox 14"/>
+          <p:cNvSpPr txBox="1"/>
+          <p:nvPr/>
+        </p:nvSpPr>
+        <p:spPr>
+          <a:xfrm>
+            <a:off x="1632857" y="4047199"/>
+            <a:ext cx="9445752" cy="685800"/>
+          </a:xfrm>
+          <a:prstGeom prst="rect">
+            <a:avLst/>
+          </a:prstGeom>
+          <a:noFill/>
+        </p:spPr>
+        <p:txBody>
+          <a:bodyPr wrap="square">
+            <a:spAutoFit/>
+          </a:bodyPr>
+          <a:lstStyle/>
+          <a:p>
+            <a:pPr algn="ctr"/>
+            <a:r>
+              <a:rPr sz="1600" b="0" i="1" dirty="0">
+                <a:solidFill>
+                  <a:srgbClr val="B87430"/>
+                </a:solidFill>
+                <a:latin typeface="Georgia"/>
+              </a:rPr>
+              <a:t>"Technology in service of the most human moments."</a:t>
+            </a:r>
+          </a:p>
+        </p:txBody>
+      </p:sp>
+      <p:sp>
+        <p:nvSpPr>
+          <p:cNvPr id="17" name="Rectangle 16"/>
           <p:cNvSpPr/>
           <p:nvPr/>
         </p:nvSpPr>
         <p:spPr>
           <a:xfrm>
-            <a:off x="2743200" y="4736592"/>
-            <a:ext cx="6702552" cy="36576"/>
+            <a:off x="0" y="6473952"/>
+            <a:ext cx="12188952" cy="18288"/>
           </a:xfrm>
           <a:prstGeom prst="rect">
             <a:avLst/>
@@ -10896,164 +10861,6 @@
           <a:p>
             <a:pPr algn="ctr"/>
             <a:endParaRPr/>
-          </a:p>
-        </p:txBody>
-      </p:sp>
-      <p:sp>
-        <p:nvSpPr>
-          <p:cNvPr id="15" name="TextBox 14"/>
-          <p:cNvSpPr txBox="1"/>
-          <p:nvPr/>
-        </p:nvSpPr>
-        <p:spPr>
-          <a:xfrm>
-            <a:off x="1371600" y="4892040"/>
-            <a:ext cx="9445752" cy="685800"/>
-          </a:xfrm>
-          <a:prstGeom prst="rect">
-            <a:avLst/>
-          </a:prstGeom>
-          <a:noFill/>
-        </p:spPr>
-        <p:txBody>
-          <a:bodyPr wrap="square">
-            <a:spAutoFit/>
-          </a:bodyPr>
-          <a:lstStyle/>
-          <a:p>
-            <a:pPr algn="ctr"/>
-            <a:r>
-              <a:rPr sz="1600" b="0" i="1">
-                <a:solidFill>
-                  <a:srgbClr val="B87430"/>
-                </a:solidFill>
-                <a:latin typeface="Georgia"/>
-              </a:rPr>
-              <a:t>"Technology in service of the most human moments."</a:t>
-            </a:r>
-          </a:p>
-        </p:txBody>
-      </p:sp>
-      <p:sp>
-        <p:nvSpPr>
-          <p:cNvPr id="16" name="Rectangle 15"/>
-          <p:cNvSpPr/>
-          <p:nvPr/>
-        </p:nvSpPr>
-        <p:spPr>
-          <a:xfrm>
-            <a:off x="0" y="6492240"/>
-            <a:ext cx="12188952" cy="365760"/>
-          </a:xfrm>
-          <a:prstGeom prst="rect">
-            <a:avLst/>
-          </a:prstGeom>
-          <a:solidFill>
-            <a:srgbClr val="F2E9DC"/>
-          </a:solidFill>
-          <a:ln>
-            <a:noFill/>
-          </a:ln>
-        </p:spPr>
-        <p:style>
-          <a:lnRef idx="1">
-            <a:schemeClr val="accent1"/>
-          </a:lnRef>
-          <a:fillRef idx="3">
-            <a:schemeClr val="accent1"/>
-          </a:fillRef>
-          <a:effectRef idx="2">
-            <a:schemeClr val="accent1"/>
-          </a:effectRef>
-          <a:fontRef idx="minor">
-            <a:schemeClr val="lt1"/>
-          </a:fontRef>
-        </p:style>
-        <p:txBody>
-          <a:bodyPr rtlCol="0" anchor="ctr"/>
-          <a:lstStyle/>
-          <a:p>
-            <a:pPr algn="ctr"/>
-            <a:endParaRPr/>
-          </a:p>
-        </p:txBody>
-      </p:sp>
-      <p:sp>
-        <p:nvSpPr>
-          <p:cNvPr id="17" name="Rectangle 16"/>
-          <p:cNvSpPr/>
-          <p:nvPr/>
-        </p:nvSpPr>
-        <p:spPr>
-          <a:xfrm>
-            <a:off x="0" y="6473952"/>
-            <a:ext cx="12188952" cy="18288"/>
-          </a:xfrm>
-          <a:prstGeom prst="rect">
-            <a:avLst/>
-          </a:prstGeom>
-          <a:solidFill>
-            <a:srgbClr val="E8D8BE"/>
-          </a:solidFill>
-          <a:ln>
-            <a:noFill/>
-          </a:ln>
-        </p:spPr>
-        <p:style>
-          <a:lnRef idx="1">
-            <a:schemeClr val="accent1"/>
-          </a:lnRef>
-          <a:fillRef idx="3">
-            <a:schemeClr val="accent1"/>
-          </a:fillRef>
-          <a:effectRef idx="2">
-            <a:schemeClr val="accent1"/>
-          </a:effectRef>
-          <a:fontRef idx="minor">
-            <a:schemeClr val="lt1"/>
-          </a:fontRef>
-        </p:style>
-        <p:txBody>
-          <a:bodyPr rtlCol="0" anchor="ctr"/>
-          <a:lstStyle/>
-          <a:p>
-            <a:pPr algn="ctr"/>
-            <a:endParaRPr/>
-          </a:p>
-        </p:txBody>
-      </p:sp>
-      <p:sp>
-        <p:nvSpPr>
-          <p:cNvPr id="18" name="TextBox 17"/>
-          <p:cNvSpPr txBox="1"/>
-          <p:nvPr/>
-        </p:nvSpPr>
-        <p:spPr>
-          <a:xfrm>
-            <a:off x="457200" y="6537960"/>
-            <a:ext cx="11247120" cy="256032"/>
-          </a:xfrm>
-          <a:prstGeom prst="rect">
-            <a:avLst/>
-          </a:prstGeom>
-          <a:noFill/>
-        </p:spPr>
-        <p:txBody>
-          <a:bodyPr wrap="square">
-            <a:spAutoFit/>
-          </a:bodyPr>
-          <a:lstStyle/>
-          <a:p>
-            <a:pPr algn="ctr"/>
-            <a:r>
-              <a:rPr sz="800" b="0" i="1">
-                <a:solidFill>
-                  <a:srgbClr val="9E7248"/>
-                </a:solidFill>
-                <a:latin typeface="Calibri"/>
-              </a:rPr>
-              <a:t>All text in this presentation is fully editable. Built with python-pptx.</a:t>
-            </a:r>
           </a:p>
         </p:txBody>
       </p:sp>
@@ -18614,7 +18421,7 @@
 </file>
 
 <file path=ppt/slides/slide6.xml><?xml version="1.0" encoding="utf-8"?>
-<p:sld xmlns:a="http://schemas.openxmlformats.org/drawingml/2006/main" xmlns:r="http://schemas.openxmlformats.org/officeDocument/2006/relationships" xmlns:p="http://schemas.openxmlformats.org/presentationml/2006/main">
+<p:sld xmlns:a="http://schemas.openxmlformats.org/drawingml/2006/main" xmlns:r="http://schemas.openxmlformats.org/officeDocument/2006/relationships" xmlns:p="http://schemas.openxmlformats.org/presentationml/2006/main" show="0">
   <p:cSld>
     <p:spTree>
       <p:nvGrpSpPr>
@@ -18638,7 +18445,7 @@
         </p:nvSpPr>
         <p:spPr>
           <a:xfrm>
-            <a:off x="0" y="0"/>
+            <a:off x="43416" y="0"/>
             <a:ext cx="12188952" cy="6858000"/>
           </a:xfrm>
           <a:prstGeom prst="rect">
@@ -18946,7 +18753,7 @@
           <a:p>
             <a:pPr algn="l"/>
             <a:r>
-              <a:rPr sz="1500" b="1" i="0">
+              <a:rPr sz="1500" b="1" i="0" dirty="0">
                 <a:solidFill>
                   <a:srgbClr val="261508"/>
                 </a:solidFill>
@@ -19676,25 +19483,23 @@
       </p:sp>
       <p:sp>
         <p:nvSpPr>
-          <p:cNvPr id="29" name="Rounded Rectangle 28"/>
+          <p:cNvPr id="33" name="Rectangle 32"/>
           <p:cNvSpPr/>
           <p:nvPr/>
         </p:nvSpPr>
         <p:spPr>
           <a:xfrm>
-            <a:off x="6035040" y="6217920"/>
-            <a:ext cx="5212080" cy="1417320"/>
-          </a:xfrm>
-          <a:prstGeom prst="roundRect">
-            <a:avLst/>
-          </a:prstGeom>
-          <a:solidFill>
-            <a:srgbClr val="D4EDEB"/>
-          </a:solidFill>
-          <a:ln w="9525">
-            <a:solidFill>
-              <a:srgbClr val="2A7A6E"/>
-            </a:solidFill>
+            <a:off x="0" y="6556248"/>
+            <a:ext cx="12188952" cy="18288"/>
+          </a:xfrm>
+          <a:prstGeom prst="rect">
+            <a:avLst/>
+          </a:prstGeom>
+          <a:solidFill>
+            <a:srgbClr val="E8D8BE"/>
+          </a:solidFill>
+          <a:ln>
+            <a:noFill/>
           </a:ln>
         </p:spPr>
         <p:style>
@@ -19717,199 +19522,6 @@
           <a:p>
             <a:pPr algn="ctr"/>
             <a:endParaRPr/>
-          </a:p>
-        </p:txBody>
-      </p:sp>
-      <p:sp>
-        <p:nvSpPr>
-          <p:cNvPr id="30" name="TextBox 29"/>
-          <p:cNvSpPr txBox="1"/>
-          <p:nvPr/>
-        </p:nvSpPr>
-        <p:spPr>
-          <a:xfrm>
-            <a:off x="6144768" y="6272784"/>
-            <a:ext cx="5029200" cy="228600"/>
-          </a:xfrm>
-          <a:prstGeom prst="rect">
-            <a:avLst/>
-          </a:prstGeom>
-          <a:noFill/>
-        </p:spPr>
-        <p:txBody>
-          <a:bodyPr wrap="square">
-            <a:spAutoFit/>
-          </a:bodyPr>
-          <a:lstStyle/>
-          <a:p>
-            <a:pPr algn="l"/>
-            <a:r>
-              <a:rPr sz="800" b="1" i="0">
-                <a:solidFill>
-                  <a:srgbClr val="2A7A6E"/>
-                </a:solidFill>
-                <a:latin typeface="Calibri"/>
-              </a:rPr>
-              <a:t>HEARTH AI</a:t>
-            </a:r>
-          </a:p>
-        </p:txBody>
-      </p:sp>
-      <p:sp>
-        <p:nvSpPr>
-          <p:cNvPr id="31" name="TextBox 30"/>
-          <p:cNvSpPr txBox="1"/>
-          <p:nvPr/>
-        </p:nvSpPr>
-        <p:spPr>
-          <a:xfrm>
-            <a:off x="6144768" y="6473952"/>
-            <a:ext cx="5029200" cy="1097280"/>
-          </a:xfrm>
-          <a:prstGeom prst="rect">
-            <a:avLst/>
-          </a:prstGeom>
-          <a:noFill/>
-        </p:spPr>
-        <p:txBody>
-          <a:bodyPr wrap="square">
-            <a:spAutoFit/>
-          </a:bodyPr>
-          <a:lstStyle/>
-          <a:p>
-            <a:pPr algn="l"/>
-            <a:r>
-              <a:rPr sz="950" b="0" i="0">
-                <a:solidFill>
-                  <a:srgbClr val="6A4220"/>
-                </a:solidFill>
-                <a:latin typeface="Calibri"/>
-              </a:rPr>
-              <a:t>In dementia care, it is rarely helpful to repeat news of a loss -- it can cause fresh grief each time. Instead, validate her feelings and redirect warmly toward comfort and memory.</a:t>
-            </a:r>
-          </a:p>
-        </p:txBody>
-      </p:sp>
-      <p:sp>
-        <p:nvSpPr>
-          <p:cNvPr id="32" name="Rectangle 31"/>
-          <p:cNvSpPr/>
-          <p:nvPr/>
-        </p:nvSpPr>
-        <p:spPr>
-          <a:xfrm>
-            <a:off x="0" y="6565392"/>
-            <a:ext cx="12188952" cy="292608"/>
-          </a:xfrm>
-          <a:prstGeom prst="rect">
-            <a:avLst/>
-          </a:prstGeom>
-          <a:solidFill>
-            <a:srgbClr val="F2E9DC"/>
-          </a:solidFill>
-          <a:ln>
-            <a:noFill/>
-          </a:ln>
-        </p:spPr>
-        <p:style>
-          <a:lnRef idx="1">
-            <a:schemeClr val="accent1"/>
-          </a:lnRef>
-          <a:fillRef idx="3">
-            <a:schemeClr val="accent1"/>
-          </a:fillRef>
-          <a:effectRef idx="2">
-            <a:schemeClr val="accent1"/>
-          </a:effectRef>
-          <a:fontRef idx="minor">
-            <a:schemeClr val="lt1"/>
-          </a:fontRef>
-        </p:style>
-        <p:txBody>
-          <a:bodyPr rtlCol="0" anchor="ctr"/>
-          <a:lstStyle/>
-          <a:p>
-            <a:pPr algn="ctr"/>
-            <a:endParaRPr/>
-          </a:p>
-        </p:txBody>
-      </p:sp>
-      <p:sp>
-        <p:nvSpPr>
-          <p:cNvPr id="33" name="Rectangle 32"/>
-          <p:cNvSpPr/>
-          <p:nvPr/>
-        </p:nvSpPr>
-        <p:spPr>
-          <a:xfrm>
-            <a:off x="0" y="6556248"/>
-            <a:ext cx="12188952" cy="18288"/>
-          </a:xfrm>
-          <a:prstGeom prst="rect">
-            <a:avLst/>
-          </a:prstGeom>
-          <a:solidFill>
-            <a:srgbClr val="E8D8BE"/>
-          </a:solidFill>
-          <a:ln>
-            <a:noFill/>
-          </a:ln>
-        </p:spPr>
-        <p:style>
-          <a:lnRef idx="1">
-            <a:schemeClr val="accent1"/>
-          </a:lnRef>
-          <a:fillRef idx="3">
-            <a:schemeClr val="accent1"/>
-          </a:fillRef>
-          <a:effectRef idx="2">
-            <a:schemeClr val="accent1"/>
-          </a:effectRef>
-          <a:fontRef idx="minor">
-            <a:schemeClr val="lt1"/>
-          </a:fontRef>
-        </p:style>
-        <p:txBody>
-          <a:bodyPr rtlCol="0" anchor="ctr"/>
-          <a:lstStyle/>
-          <a:p>
-            <a:pPr algn="ctr"/>
-            <a:endParaRPr/>
-          </a:p>
-        </p:txBody>
-      </p:sp>
-      <p:sp>
-        <p:nvSpPr>
-          <p:cNvPr id="34" name="TextBox 33"/>
-          <p:cNvSpPr txBox="1"/>
-          <p:nvPr/>
-        </p:nvSpPr>
-        <p:spPr>
-          <a:xfrm>
-            <a:off x="365760" y="6583680"/>
-            <a:ext cx="11430000" cy="228600"/>
-          </a:xfrm>
-          <a:prstGeom prst="rect">
-            <a:avLst/>
-          </a:prstGeom>
-          <a:noFill/>
-        </p:spPr>
-        <p:txBody>
-          <a:bodyPr wrap="square">
-            <a:spAutoFit/>
-          </a:bodyPr>
-          <a:lstStyle/>
-          <a:p>
-            <a:pPr algn="ctr"/>
-            <a:r>
-              <a:rPr sz="800" b="0" i="0">
-                <a:solidFill>
-                  <a:srgbClr val="9E7248"/>
-                </a:solidFill>
-                <a:latin typeface="Calibri"/>
-              </a:rPr>
-              <a:t>Hearth AI  |  BUAN 6V99  |  Spring 2026  |  Nikhil Gajula</a:t>
-            </a:r>
           </a:p>
         </p:txBody>
       </p:sp>

</xml_diff>